<commit_message>
Reports: rebuild in progress with the left off / deleted wording (work in progress)
Co-Authored-By: Claude Opus 5.5 <noreply@anthropic.com>
Claude-Session: https://claude.ai/code/session_012JjD5mhtvLxzAXoZHMZYE5
</commit_message>
<xml_diff>
--- a/reports/delhi-sir-2026-deck.pptx
+++ b/reports/delhi-sir-2026-deck.pptx
@@ -1770,7 +1770,7 @@
       </p:sp>
       <p:pic>
         <p:nvPicPr>
-          <p:cNvPr id="4" name="Image 0" descr="/tmp/pack-7qNEwO/dl-delhi-1.png">    </p:cNvPr>
+          <p:cNvPr id="4" name="Image 0" descr="/tmp/pack-BpyxFC/dl-delhi-1.png">    </p:cNvPr>
           <p:cNvPicPr>
             <a:picLocks noChangeAspect="1"/>
           </p:cNvPicPr>
@@ -1943,7 +1943,7 @@
       </p:sp>
       <p:pic>
         <p:nvPicPr>
-          <p:cNvPr id="4" name="Image 0" descr="/tmp/pack-7qNEwO/dl-delhi-2.png">    </p:cNvPr>
+          <p:cNvPr id="4" name="Image 0" descr="/tmp/pack-BpyxFC/dl-delhi-2.png">    </p:cNvPr>
           <p:cNvPicPr>
             <a:picLocks noChangeAspect="1"/>
           </p:cNvPicPr>
@@ -2116,7 +2116,7 @@
       </p:sp>
       <p:pic>
         <p:nvPicPr>
-          <p:cNvPr id="4" name="Image 0" descr="/tmp/pack-7qNEwO/dl-delhi-3.png">    </p:cNvPr>
+          <p:cNvPr id="4" name="Image 0" descr="/tmp/pack-BpyxFC/dl-delhi-3.png">    </p:cNvPr>
           <p:cNvPicPr>
             <a:picLocks noChangeAspect="1"/>
           </p:cNvPicPr>
@@ -2328,7 +2328,7 @@
       </p:sp>
       <p:pic>
         <p:nvPicPr>
-          <p:cNvPr id="4" name="Image 0" descr="/tmp/pack-7qNEwO/dl-delhi-4.png">    </p:cNvPr>
+          <p:cNvPr id="4" name="Image 0" descr="/tmp/pack-BpyxFC/dl-delhi-4.png">    </p:cNvPr>
           <p:cNvPicPr>
             <a:picLocks noChangeAspect="1"/>
           </p:cNvPicPr>
@@ -2501,7 +2501,7 @@
       </p:sp>
       <p:pic>
         <p:nvPicPr>
-          <p:cNvPr id="4" name="Image 0" descr="/tmp/pack-7qNEwO/dl-delhi-5.png">    </p:cNvPr>
+          <p:cNvPr id="4" name="Image 0" descr="/tmp/pack-BpyxFC/dl-delhi-5.png">    </p:cNvPr>
           <p:cNvPicPr>
             <a:picLocks noChangeAspect="1"/>
           </p:cNvPicPr>

</xml_diff>